<commit_message>
Finalize English-only research submission and validated deliverables
</commit_message>
<xml_diff>
--- a/output/slides.pptx
+++ b/output/slides.pptx
@@ -214,13 +214,13 @@
                 <c:formatCode>0.0</c:formatCode>
                 <c:ptCount val="3"/>
                 <c:pt idx="0">
-                  <c:v>22.608695999999998</c:v>
+                  <c:v>22.608696</c:v>
                 </c:pt>
                 <c:pt idx="1">
-                  <c:v>23.913042999999998</c:v>
+                  <c:v>23.913043</c:v>
                 </c:pt>
                 <c:pt idx="2">
-                  <c:v>45.217390999999999</c:v>
+                  <c:v>45.217391</c:v>
                 </c:pt>
               </c:numCache>
             </c:numRef>
@@ -307,13 +307,13 @@
                 <c:formatCode>0.0</c:formatCode>
                 <c:ptCount val="3"/>
                 <c:pt idx="0">
-                  <c:v>49.577804999999998</c:v>
+                  <c:v>49.577805</c:v>
                 </c:pt>
                 <c:pt idx="1">
                   <c:v>86.127865</c:v>
                 </c:pt>
                 <c:pt idx="2">
-                  <c:v>53.075994999999999</c:v>
+                  <c:v>53.075995</c:v>
                 </c:pt>
               </c:numCache>
             </c:numRef>
@@ -576,10 +576,10 @@
                   <c:v>55.2</c:v>
                 </c:pt>
                 <c:pt idx="1">
-                  <c:v>60.834496999999999</c:v>
+                  <c:v>60.834497</c:v>
                 </c:pt>
                 <c:pt idx="2">
-                  <c:v>66.129884000000004</c:v>
+                  <c:v>66.129884</c:v>
                 </c:pt>
                 <c:pt idx="3">
                   <c:v>51.7</c:v>
@@ -825,55 +825,55 @@
                 <c:formatCode>0</c:formatCode>
                 <c:ptCount val="17"/>
                 <c:pt idx="0">
-                  <c:v>71.841667000000001</c:v>
+                  <c:v>71.841667</c:v>
                 </c:pt>
                 <c:pt idx="1">
-                  <c:v>67.349999999999994</c:v>
+                  <c:v>67.35</c:v>
                 </c:pt>
                 <c:pt idx="2">
-                  <c:v>76.541667000000004</c:v>
+                  <c:v>76.541667</c:v>
                 </c:pt>
                 <c:pt idx="3">
-                  <c:v>79.208332999999996</c:v>
+                  <c:v>79.208333</c:v>
                 </c:pt>
                 <c:pt idx="4">
                   <c:v>84.125</c:v>
                 </c:pt>
                 <c:pt idx="5">
-                  <c:v>92.941666999999995</c:v>
+                  <c:v>92.941667</c:v>
                 </c:pt>
                 <c:pt idx="6">
-                  <c:v>91.841667000000001</c:v>
+                  <c:v>91.841667</c:v>
                 </c:pt>
                 <c:pt idx="7">
-                  <c:v>96.766666999999998</c:v>
+                  <c:v>96.766667</c:v>
                 </c:pt>
                 <c:pt idx="8">
-                  <c:v>98.366667000000007</c:v>
+                  <c:v>98.366667</c:v>
                 </c:pt>
                 <c:pt idx="9">
-                  <c:v>95.983333000000002</c:v>
+                  <c:v>95.983333</c:v>
                 </c:pt>
                 <c:pt idx="10">
-                  <c:v>81.541667000000004</c:v>
+                  <c:v>81.541667</c:v>
                 </c:pt>
                 <c:pt idx="11">
-                  <c:v>77.616667000000007</c:v>
+                  <c:v>77.616667</c:v>
                 </c:pt>
                 <c:pt idx="12">
-                  <c:v>58.975000000000001</c:v>
+                  <c:v>58.975</c:v>
                 </c:pt>
                 <c:pt idx="13">
-                  <c:v>65.349999999999994</c:v>
+                  <c:v>65.35</c:v>
                 </c:pt>
                 <c:pt idx="14">
-                  <c:v>72.541667000000004</c:v>
+                  <c:v>72.541667</c:v>
                 </c:pt>
                 <c:pt idx="15">
-                  <c:v>57.583333000000003</c:v>
+                  <c:v>57.583333</c:v>
                 </c:pt>
                 <c:pt idx="16">
-                  <c:v>52.162500000000001</c:v>
+                  <c:v>52.1625</c:v>
                 </c:pt>
               </c:numCache>
             </c:numRef>
@@ -967,55 +967,55 @@
                 <c:formatCode>0</c:formatCode>
                 <c:ptCount val="17"/>
                 <c:pt idx="0">
-                  <c:v>72.289474999999996</c:v>
+                  <c:v>72.289475</c:v>
                 </c:pt>
                 <c:pt idx="1">
-                  <c:v>70.522839000000005</c:v>
+                  <c:v>70.522839</c:v>
                 </c:pt>
                 <c:pt idx="2">
-                  <c:v>74.072478000000004</c:v>
+                  <c:v>74.072478</c:v>
                 </c:pt>
                 <c:pt idx="3">
-                  <c:v>81.622753000000003</c:v>
+                  <c:v>81.622753</c:v>
                 </c:pt>
                 <c:pt idx="4">
-                  <c:v>83.235535999999996</c:v>
+                  <c:v>83.235536</c:v>
                 </c:pt>
                 <c:pt idx="5">
-                  <c:v>92.060073000000003</c:v>
+                  <c:v>92.060073</c:v>
                 </c:pt>
                 <c:pt idx="6">
-                  <c:v>89.620220000000003</c:v>
+                  <c:v>89.62022</c:v>
                 </c:pt>
                 <c:pt idx="7">
-                  <c:v>85.571535999999995</c:v>
+                  <c:v>85.571536</c:v>
                 </c:pt>
                 <c:pt idx="8">
-                  <c:v>84.049355000000006</c:v>
+                  <c:v>84.049355</c:v>
                 </c:pt>
                 <c:pt idx="9">
-                  <c:v>88.158112000000003</c:v>
+                  <c:v>88.158112</c:v>
                 </c:pt>
                 <c:pt idx="10">
-                  <c:v>81.034284999999997</c:v>
+                  <c:v>81.034285</c:v>
                 </c:pt>
                 <c:pt idx="11">
-                  <c:v>71.401690000000002</c:v>
+                  <c:v>71.40169</c:v>
                 </c:pt>
                 <c:pt idx="12">
-                  <c:v>52.380498000000003</c:v>
+                  <c:v>52.380498</c:v>
                 </c:pt>
                 <c:pt idx="13">
-                  <c:v>68.705710999999994</c:v>
+                  <c:v>68.705711</c:v>
                 </c:pt>
                 <c:pt idx="14">
-                  <c:v>80.368725999999995</c:v>
+                  <c:v>80.368726</c:v>
                 </c:pt>
                 <c:pt idx="15">
-                  <c:v>79.433980000000005</c:v>
+                  <c:v>79.43398</c:v>
                 </c:pt>
                 <c:pt idx="16">
-                  <c:v>73.234097000000006</c:v>
+                  <c:v>73.234097</c:v>
                 </c:pt>
               </c:numCache>
             </c:numRef>
@@ -1109,55 +1109,55 @@
                 <c:formatCode>0</c:formatCode>
                 <c:ptCount val="17"/>
                 <c:pt idx="0">
-                  <c:v>74.848218000000003</c:v>
+                  <c:v>74.848218</c:v>
                 </c:pt>
                 <c:pt idx="1">
-                  <c:v>73.838579999999993</c:v>
+                  <c:v>73.83858</c:v>
                 </c:pt>
                 <c:pt idx="2">
                   <c:v>77.347932</c:v>
                 </c:pt>
                 <c:pt idx="3">
-                  <c:v>83.340781000000007</c:v>
+                  <c:v>83.340781</c:v>
                 </c:pt>
                 <c:pt idx="4">
-                  <c:v>87.059697999999997</c:v>
+                  <c:v>87.059698</c:v>
                 </c:pt>
                 <c:pt idx="5">
-                  <c:v>95.172949000000003</c:v>
+                  <c:v>95.172949</c:v>
                 </c:pt>
                 <c:pt idx="6">
-                  <c:v>94.302058000000002</c:v>
+                  <c:v>94.302058</c:v>
                 </c:pt>
                 <c:pt idx="7">
-                  <c:v>91.716650999999999</c:v>
+                  <c:v>91.716651</c:v>
                 </c:pt>
                 <c:pt idx="8">
-                  <c:v>90.412807000000001</c:v>
+                  <c:v>90.412807</c:v>
                 </c:pt>
                 <c:pt idx="9">
-                  <c:v>92.362566999999999</c:v>
+                  <c:v>92.362567</c:v>
                 </c:pt>
                 <c:pt idx="10">
-                  <c:v>74.854403000000005</c:v>
+                  <c:v>74.854403</c:v>
                 </c:pt>
                 <c:pt idx="11">
-                  <c:v>70.282585999999995</c:v>
+                  <c:v>70.282586</c:v>
                 </c:pt>
                 <c:pt idx="12">
                   <c:v>59.912785</c:v>
                 </c:pt>
                 <c:pt idx="13">
-                  <c:v>65.767600000000002</c:v>
+                  <c:v>65.7676</c:v>
                 </c:pt>
                 <c:pt idx="14">
-                  <c:v>69.091049999999996</c:v>
+                  <c:v>69.09105</c:v>
                 </c:pt>
                 <c:pt idx="15">
-                  <c:v>64.885790999999998</c:v>
+                  <c:v>64.885791</c:v>
                 </c:pt>
                 <c:pt idx="16">
-                  <c:v>57.230317999999997</c:v>
+                  <c:v>57.230318</c:v>
                 </c:pt>
               </c:numCache>
             </c:numRef>
@@ -1404,10 +1404,10 @@
                   <c:v>113.864448</c:v>
                 </c:pt>
                 <c:pt idx="4">
-                  <c:v>118.15658999999999</c:v>
+                  <c:v>118.15659</c:v>
                 </c:pt>
                 <c:pt idx="5">
-                  <c:v>120.67068500000001</c:v>
+                  <c:v>120.670685</c:v>
                 </c:pt>
                 <c:pt idx="6">
                   <c:v>123.937449</c:v>
@@ -1614,22 +1614,22 @@
                   <c:v>1.33369</c:v>
                 </c:pt>
                 <c:pt idx="1">
-                  <c:v>1.3724620000000001</c:v>
+                  <c:v>1.372462</c:v>
                 </c:pt>
                 <c:pt idx="2">
-                  <c:v>4.3808619999999996</c:v>
+                  <c:v>4.380862</c:v>
                 </c:pt>
                 <c:pt idx="3">
-                  <c:v>6.2444350000000002</c:v>
+                  <c:v>6.244435</c:v>
                 </c:pt>
                 <c:pt idx="4">
-                  <c:v>3.4386350000000001</c:v>
+                  <c:v>3.438635</c:v>
                 </c:pt>
                 <c:pt idx="5">
-                  <c:v>2.0949529999999998</c:v>
+                  <c:v>2.094953</c:v>
                 </c:pt>
                 <c:pt idx="6">
-                  <c:v>2.7411629999999998</c:v>
+                  <c:v>2.741163</c:v>
                 </c:pt>
                 <c:pt idx="7">
                   <c:v>3.668053</c:v>
@@ -1858,16 +1858,16 @@
                 <c:formatCode>0.0</c:formatCode>
                 <c:ptCount val="4"/>
                 <c:pt idx="0">
-                  <c:v>8.2608700000000006</c:v>
+                  <c:v>8.26087</c:v>
                 </c:pt>
                 <c:pt idx="1">
-                  <c:v>22.608695999999998</c:v>
+                  <c:v>22.608696</c:v>
                 </c:pt>
                 <c:pt idx="2">
-                  <c:v>25.652173999999999</c:v>
+                  <c:v>25.652174</c:v>
                 </c:pt>
                 <c:pt idx="3">
-                  <c:v>45.217390999999999</c:v>
+                  <c:v>45.217391</c:v>
                 </c:pt>
               </c:numCache>
             </c:numRef>
@@ -1964,13 +1964,13 @@
                   <c:v>10.494572</c:v>
                 </c:pt>
                 <c:pt idx="1">
-                  <c:v>49.577804999999998</c:v>
+                  <c:v>49.577805</c:v>
                 </c:pt>
                 <c:pt idx="2">
-                  <c:v>37.635705999999999</c:v>
+                  <c:v>37.635706</c:v>
                 </c:pt>
                 <c:pt idx="3">
-                  <c:v>53.075994999999999</c:v>
+                  <c:v>53.075995</c:v>
                 </c:pt>
               </c:numCache>
             </c:numRef>
@@ -2232,7 +2232,7 @@
                   <c:v>4.030138</c:v>
                 </c:pt>
                 <c:pt idx="2">
-                  <c:v>4.1986739999999996</c:v>
+                  <c:v>4.198674</c:v>
                 </c:pt>
               </c:numCache>
             </c:numRef>
@@ -2319,13 +2319,13 @@
                 <c:formatCode>0.000</c:formatCode>
                 <c:ptCount val="3"/>
                 <c:pt idx="0">
-                  <c:v>3.5269210000000002</c:v>
+                  <c:v>3.526921</c:v>
                 </c:pt>
                 <c:pt idx="1">
-                  <c:v>4.0043329999999999</c:v>
+                  <c:v>4.004333</c:v>
                 </c:pt>
                 <c:pt idx="2">
-                  <c:v>4.1980919999999999</c:v>
+                  <c:v>4.198092</c:v>
                 </c:pt>
               </c:numCache>
             </c:numRef>
@@ -2581,13 +2581,13 @@
                 <c:formatCode>0.00</c:formatCode>
                 <c:ptCount val="3"/>
                 <c:pt idx="0">
-                  <c:v>0.29886000000000001</c:v>
+                  <c:v>0.29886</c:v>
                 </c:pt>
                 <c:pt idx="1">
-                  <c:v>-0.19322400000000001</c:v>
+                  <c:v>-0.193224</c:v>
                 </c:pt>
                 <c:pt idx="2">
-                  <c:v>-0.33027099999999998</c:v>
+                  <c:v>-0.330271</c:v>
                 </c:pt>
               </c:numCache>
             </c:numRef>
@@ -3051,76 +3051,98 @@
           <a:lstStyle/>
           <a:p>
             <a:r>
-              <a:rPr dirty="0"/>
-              <a:t>X contains more emotional language and political blame in our sample.</a:t>
-            </a:r>
-          </a:p>
-          <a:p>
-            <a:endParaRPr dirty="0"/>
-          </a:p>
-          <a:p>
-            <a:r>
-              <a:rPr dirty="0"/>
-              <a:t>Our clearest economic finding is that accumulated price pressure reduces the unexplained sentiment gap.</a:t>
-            </a:r>
-          </a:p>
-          <a:p>
-            <a:endParaRPr dirty="0"/>
-          </a:p>
-          <a:p>
-            <a:r>
-              <a:rPr dirty="0"/>
-              <a:t>Media improves forecasts in some models, but the improvement depends on the controls and coverage rule.</a:t>
-            </a:r>
-          </a:p>
-          <a:p>
-            <a:endParaRPr dirty="0"/>
-          </a:p>
-          <a:p>
-            <a:r>
-              <a:rPr dirty="0"/>
-              <a:t>For forecasting, we should pay attention to purchasing power and the latest sentiment reading before adding more text features. The shopping bill turned out to be an important part of the research.</a:t>
-            </a:r>
-          </a:p>
-          <a:p>
-            <a:endParaRPr dirty="0"/>
-          </a:p>
-          <a:p>
-            <a:r>
-              <a:rPr dirty="0"/>
+              <a:t>X shows more emotional language and political blame in our sample.</a:t>
+            </a:r>
+          </a:p>
+          <a:p>
+            <a:r>
+              <a:t/>
+            </a:r>
+            <a:endParaRPr/>
+          </a:p>
+          <a:p>
+            <a:r>
+              <a:t>Accumulated price pressure reduces the unexplained sentiment gap.</a:t>
+            </a:r>
+          </a:p>
+          <a:p>
+            <a:r>
+              <a:t/>
+            </a:r>
+            <a:endParaRPr/>
+          </a:p>
+          <a:p>
+            <a:r>
+              <a:t>Media sometimes lowers forecast errors, but the gain remains uncertain after the additional checks.</a:t>
+            </a:r>
+          </a:p>
+          <a:p>
+            <a:r>
+              <a:t/>
+            </a:r>
+            <a:endParaRPr/>
+          </a:p>
+          <a:p>
+            <a:r>
+              <a:t>For financial risk monitoring, the August example shows why the benchmark matters. The gap is about fourteen points against the economy-only forecast, but three and a half against prior sentiment.</a:t>
+            </a:r>
+          </a:p>
+          <a:p>
+            <a:r>
+              <a:t/>
+            </a:r>
+            <a:endParaRPr/>
+          </a:p>
+          <a:p>
+            <a:r>
+              <a:t>Before treating that gap as new risk information, examine purchasing power and recent sentiment. Media signals need to show additional forecasting value.</a:t>
+            </a:r>
+          </a:p>
+          <a:p>
+            <a:r>
+              <a:t/>
+            </a:r>
+            <a:endParaRPr/>
+          </a:p>
+          <a:p>
+            <a:r>
               <a:t>Thank you.</a:t>
             </a:r>
           </a:p>
           <a:p>
-            <a:endParaRPr dirty="0"/>
-          </a:p>
-          <a:p>
-            <a:r>
-              <a:rPr dirty="0"/>
+            <a:r>
+              <a:t/>
+            </a:r>
+          </a:p>
+          <a:p>
+            <a:r>
               <a:t>Sources</a:t>
             </a:r>
-          </a:p>
-          <a:p>
-            <a:r>
-              <a:rPr dirty="0"/>
-              <a:t>Report pages 1, 5–9</a:t>
-            </a:r>
-          </a:p>
-          <a:p>
-            <a:r>
-              <a:rPr dirty="0"/>
-              <a:t>reports/gpt_core_v3/</a:t>
-            </a:r>
-            <a:r>
-              <a:rPr dirty="0" err="1"/>
-              <a:t>analysis.json</a:t>
-            </a:r>
-            <a:endParaRPr dirty="0"/>
-          </a:p>
-          <a:p>
-            <a:r>
-              <a:rPr dirty="0"/>
-              <a:t>Final main slide. No methods appendix follows.</a:t>
+            <a:endParaRPr/>
+          </a:p>
+          <a:p>
+            <a:r>
+              <a:t>Report pages 1, 4–9</a:t>
+            </a:r>
+          </a:p>
+          <a:p>
+            <a:r>
+              <a:t>data/processed/gpt_core_v3/predictions.csv</a:t>
+            </a:r>
+          </a:p>
+          <a:p>
+            <a:r>
+              <a:t>reports/gpt_core_v3/analysis.json</a:t>
+            </a:r>
+          </a:p>
+          <a:p>
+            <a:r>
+              <a:t>reports/rubric_extension/statistical_stability.json</a:t>
+            </a:r>
+          </a:p>
+          <a:p>
+            <a:r>
+              <a:t>August 2026 observed-minus-predicted sentiment gaps: 51.7-66.1298 approximately -14.4, and 51.7-55.2=-3.5. Rounded illustration from existing forecasts, not an estimated asset-return or risk model. Final main slide. No methods appendix follows.</a:t>
             </a:r>
           </a:p>
         </p:txBody>
@@ -3313,72 +3335,103 @@
           <a:lstStyle/>
           <a:p>
             <a:r>
-              <a:rPr lang="en-US" altLang="zh-CN" dirty="0"/>
               <a:t>We measure tone, topic salience, framing and political blame separately. </a:t>
             </a:r>
-            <a:endParaRPr lang="en-US" dirty="0"/>
-          </a:p>
-          <a:p>
-            <a:endParaRPr lang="en-US" dirty="0"/>
-          </a:p>
-          <a:p>
-            <a:r>
-              <a:rPr lang="en-US" dirty="0"/>
-              <a:t>We found that </a:t>
-            </a:r>
-            <a:r>
-              <a:rPr dirty="0"/>
-              <a:t>X uses much more emotional or mixed language in our sample: eighty-six percent, compared with twenty-four percent in news headlines. Political blame is also more common on X.</a:t>
-            </a:r>
-          </a:p>
-          <a:p>
-            <a:endParaRPr dirty="0"/>
-          </a:p>
-          <a:p>
-            <a:r>
-              <a:rPr dirty="0"/>
+            <a:endParaRPr/>
+          </a:p>
+          <a:p>
+            <a:r>
+              <a:t/>
+            </a:r>
+            <a:endParaRPr/>
+          </a:p>
+          <a:p>
+            <a:r>
+              <a:t>We found that X uses much more emotional or mixed language in our sample: eighty-six percent, compared with twenty-four percent in news headlines. Political blame is also more common on X.</a:t>
+            </a:r>
+          </a:p>
+          <a:p>
+            <a:r>
+              <a:t/>
+            </a:r>
+            <a:endParaRPr/>
+          </a:p>
+          <a:p>
+            <a:r>
               <a:t>The gap in negative economic tone is smaller: fifty-three percent on X and forty-five percent in news. </a:t>
             </a:r>
           </a:p>
           <a:p>
-            <a:endParaRPr dirty="0"/>
-          </a:p>
-          <a:p>
-            <a:r>
-              <a:rPr dirty="0"/>
-              <a:t>Our sample includes two hundred and thirty headlines and eight hundred and twenty-nine posts, from October 2019 to July 2026.</a:t>
-            </a:r>
-          </a:p>
-          <a:p>
-            <a:endParaRPr dirty="0"/>
-          </a:p>
-          <a:p>
-            <a:r>
-              <a:rPr dirty="0"/>
+            <a:r>
+              <a:t/>
+            </a:r>
+            <a:endParaRPr/>
+          </a:p>
+          <a:p>
+            <a:r>
+              <a:t>One human annotator provides the reference labels. The comparison shows that the coding still makes mistakes.</a:t>
+            </a:r>
+          </a:p>
+          <a:p>
+            <a:r>
+              <a:t/>
+            </a:r>
+            <a:endParaRPr/>
+          </a:p>
+          <a:p>
+            <a:r>
+              <a:t>We also compared headlines about the same economic releases. In May 2023, payrolls grew while unemployment also rose. One headline emphasized job growth, while another mentioned both. Different emphasis alone does not establish bias.</a:t>
+            </a:r>
+          </a:p>
+          <a:p>
+            <a:r>
+              <a:t/>
+            </a:r>
+          </a:p>
+          <a:p>
+            <a:r>
               <a:t>Sources</a:t>
             </a:r>
-          </a:p>
-          <a:p>
-            <a:r>
-              <a:rPr dirty="0"/>
+            <a:endParaRPr/>
+          </a:p>
+          <a:p>
+            <a:r>
               <a:t>Report page 3</a:t>
             </a:r>
           </a:p>
           <a:p>
             <a:r>
-              <a:rPr dirty="0"/>
-              <a:t>reports/gpt_core_v3/</a:t>
-            </a:r>
-            <a:r>
-              <a:rPr dirty="0" err="1"/>
-              <a:t>descriptive.json</a:t>
-            </a:r>
-            <a:endParaRPr dirty="0"/>
-          </a:p>
-          <a:p>
-            <a:r>
-              <a:rPr dirty="0"/>
+              <a:t>reports/gpt_core_v3/descriptive.json</a:t>
+            </a:r>
+          </a:p>
+          <a:p>
+            <a:r>
               <a:t>Political blame includes texts assigning both credit and blame. Sample content differences do not establish a platform causal effect.</a:t>
+            </a:r>
+          </a:p>
+          <a:p>
+            <a:r>
+              <a:t>Report page 10</a:t>
+            </a:r>
+          </a:p>
+          <a:p>
+            <a:r>
+              <a:t>reports/rubric_extension/measurement.json</a:t>
+            </a:r>
+          </a:p>
+          <a:p>
+            <a:r>
+              <a:t>reports/rubric_extension/same_event_comparison.json</a:t>
+            </a:r>
+          </a:p>
+          <a:p>
+            <a:r>
+              <a:t>https://www.bls.gov/news.release/archives/empsit_06022023.htm</a:t>
+            </a:r>
+          </a:p>
+          <a:p>
+            <a:r>
+              <a:t>Tone macro-F1 0.602 is the five-class held-out comparison: 196 valid pairs from 200 held-out reference items. One independent human annotator, not a consensus reference.</a:t>
             </a:r>
           </a:p>
         </p:txBody>
@@ -3708,52 +3761,54 @@
           <a:lstStyle/>
           <a:p>
             <a:r>
-              <a:rPr dirty="0"/>
               <a:t>The top chart shows the accumulated price increase. By our latest forecast date, prices were almost twenty-eight percent above December 2018.</a:t>
             </a:r>
           </a:p>
           <a:p>
-            <a:endParaRPr dirty="0"/>
-          </a:p>
-          <a:p>
-            <a:r>
-              <a:rPr dirty="0"/>
+            <a:r>
+              <a:t/>
+            </a:r>
+            <a:endParaRPr/>
+          </a:p>
+          <a:p>
+            <a:r>
               <a:t>The bottom chart shows inflation. It was about three point seven percent. Prices are still rising from an already higher level. Real disposable income was growing by only about half a percent.</a:t>
             </a:r>
           </a:p>
           <a:p>
-            <a:endParaRPr dirty="0"/>
-          </a:p>
-          <a:p>
-            <a:r>
-              <a:rPr dirty="0"/>
-              <a:t>Adding accumulated price increases made our economic forecasts more accurate. This suggests that the higher cost of living helps explain why consumer sentiment remains low.</a:t>
-            </a:r>
-          </a:p>
-          <a:p>
-            <a:endParaRPr dirty="0"/>
-          </a:p>
-          <a:p>
-            <a:r>
-              <a:rPr dirty="0"/>
+            <a:r>
+              <a:t/>
+            </a:r>
+            <a:endParaRPr/>
+          </a:p>
+          <a:p>
+            <a:r>
+              <a:t>Adding accumulated prices reduced errors in the economy-only forecasts. This suggests that the higher cost of living helps explain why consumer sentiment remains low.</a:t>
+            </a:r>
+          </a:p>
+          <a:p>
+            <a:r>
+              <a:t/>
+            </a:r>
+            <a:endParaRPr/>
+          </a:p>
+          <a:p>
+            <a:r>
               <a:t>Sources</a:t>
             </a:r>
           </a:p>
           <a:p>
             <a:r>
-              <a:rPr dirty="0"/>
               <a:t>Report page 6</a:t>
             </a:r>
           </a:p>
           <a:p>
             <a:r>
-              <a:rPr dirty="0"/>
               <a:t>data/processed/gpt_core_v3/model_panel.csv</a:t>
             </a:r>
           </a:p>
           <a:p>
             <a:r>
-              <a:rPr dirty="0"/>
               <a:t>PCEPI reference December 2018, numerator and denominator from the same origin vintage. DSPIC96 income growth is aggregate real disposable income, not household microdata.</a:t>
             </a:r>
           </a:p>
@@ -3967,6 +4022,9 @@
             </a:r>
           </a:p>
           <a:p>
+            <a:r>
+              <a:t/>
+            </a:r>
             <a:endParaRPr/>
           </a:p>
           <a:p>
@@ -3975,22 +4033,31 @@
             </a:r>
           </a:p>
           <a:p>
+            <a:r>
+              <a:t/>
+            </a:r>
             <a:endParaRPr/>
           </a:p>
           <a:p>
             <a:r>
-              <a:t>With seasonality and survey-mode controls, adding media tone lowers the error from three point eight six to three point five three. The survey-mode control reflects Michigan's switch to web surveys in 2024.</a:t>
-            </a:r>
-          </a:p>
-          <a:p>
+              <a:t>With seasonality and survey-mode controls, adding media tone lowers the error from three point eight six to three point five three. But after correcting for multiple model comparisons, the evidence is too weak to call the gain statistically significant.</a:t>
+            </a:r>
+          </a:p>
+          <a:p>
+            <a:r>
+              <a:t/>
+            </a:r>
             <a:endParaRPr/>
           </a:p>
           <a:p>
             <a:r>
-              <a:t>The improvement reverses under the strictest coverage rule. We also cannot clearly say this model beats carrying forward prior sentiment. Adding all the content features raises the error to four point seven four. More features do not always give a better forecast.</a:t>
-            </a:r>
-          </a:p>
-          <a:p>
+              <a:t>The model also does not clearly beat carrying forward prior sentiment. Adding all the content features raises the error to four point seven four. More features do not always give a better forecast.</a:t>
+            </a:r>
+          </a:p>
+          <a:p>
+            <a:r>
+              <a:t/>
+            </a:r>
             <a:endParaRPr/>
           </a:p>
           <a:p>
@@ -4010,12 +4077,17 @@
           </a:p>
           <a:p>
             <a:r>
+              <a:t>reports/rubric_extension/statistical_stability.json</a:t>
+            </a:r>
+          </a:p>
+          <a:p>
+            <a:r>
               <a:t>https://www.sca.isr.umich.edu/files/methodtransitionannouncement2024.pdf</a:t>
             </a:r>
           </a:p>
           <a:p>
             <a:r>
-              <a:t>Method controls contain the economy and prior sentiment plus annual sine/cosine and a transition ramp. They do not also contain household controls. The nominal paired media-gain interval excludes zero, but multiplicity and coding uncertainty are not included.</a:t>
+              <a:t>Method controls contain the economy and prior sentiment plus annual sine/cosine and a transition ramp. They do not also contain household controls. Original MAEs and nominal paired intervals are unchanged. Separate retrospective exploratory Holm correction across 14 original comparisons: raw p=0.0105, adjusted p=0.147 for the method-controls media gain. Null-centered 3-month block bootstrap, 3,999 replications. Coding uncertainty is not propagated.</a:t>
             </a:r>
           </a:p>
         </p:txBody>
@@ -4092,61 +4164,65 @@
           <a:lstStyle/>
           <a:p>
             <a:r>
-              <a:rPr dirty="0"/>
               <a:t>We found two reasons to question a strong media explanation. Adding price levels greatly reduces the economic model's unexplained gap. And the forecasting benefit from media changes with the coverage rule.</a:t>
             </a:r>
           </a:p>
           <a:p>
-            <a:endParaRPr dirty="0"/>
-          </a:p>
-          <a:p>
-            <a:r>
-              <a:rPr dirty="0"/>
+            <a:r>
+              <a:t/>
+            </a:r>
+            <a:endParaRPr/>
+          </a:p>
+          <a:p>
+            <a:r>
               <a:t>In this chart, negative values mean that media improves the forecast. With at least three news headlines and five X posts per month, the error goes up instead. Only thirteen months remain under that rule, so the conclusion depends on which months we can use.</a:t>
             </a:r>
           </a:p>
           <a:p>
-            <a:endParaRPr dirty="0"/>
-          </a:p>
-          <a:p>
-            <a:r>
-              <a:rPr dirty="0"/>
-              <a:t>To study this further, we should compare coverage of the same economic releases and link actual media exposure to survey responses. We should also collect household budgets and the past prices people use as a reference. This would help separate media framing from the pressure of higher prices.</a:t>
-            </a:r>
-          </a:p>
-          <a:p>
-            <a:endParaRPr dirty="0"/>
-          </a:p>
-          <a:p>
-            <a:r>
-              <a:rPr dirty="0"/>
+            <a:r>
+              <a:t/>
+            </a:r>
+            <a:endParaRPr/>
+          </a:p>
+          <a:p>
+            <a:r>
+              <a:t>We have now compared headlines about the same economic releases. Differences in emphasis do not by themselves establish bias. Longer-lag forecasting gains also remain uncertain. A stronger causal study would link actual media exposure to later survey responses while accounting for household financial conditions.</a:t>
+            </a:r>
+          </a:p>
+          <a:p>
+            <a:r>
+              <a:t/>
+            </a:r>
+            <a:endParaRPr/>
+          </a:p>
+          <a:p>
+            <a:r>
               <a:t>Sources</a:t>
             </a:r>
           </a:p>
           <a:p>
             <a:r>
-              <a:rPr dirty="0"/>
-              <a:t>Report page 9</a:t>
-            </a:r>
-          </a:p>
-          <a:p>
-            <a:r>
-              <a:rPr dirty="0"/>
-              <a:t>reports/gpt_core_v3/</a:t>
-            </a:r>
-            <a:r>
-              <a:rPr dirty="0" err="1"/>
-              <a:t>analysis.json</a:t>
-            </a:r>
-            <a:r>
-              <a:rPr dirty="0"/>
-              <a:t>: sensitivity</a:t>
-            </a:r>
-          </a:p>
-          <a:p>
-            <a:r>
-              <a:rPr dirty="0"/>
-              <a:t>The 13-month change interval crosses zero. A coverage sensitivity is not an isolated measurement-precision experiment.</a:t>
+              <a:t>Report pages 3 and 9</a:t>
+            </a:r>
+          </a:p>
+          <a:p>
+            <a:r>
+              <a:t>reports/gpt_core_v3/analysis.json: sensitivity</a:t>
+            </a:r>
+          </a:p>
+          <a:p>
+            <a:r>
+              <a:t>reports/rubric_extension/statistical_stability.json</a:t>
+            </a:r>
+          </a:p>
+          <a:p>
+            <a:r>
+              <a:t>reports/rubric_extension/same_event_comparison.json</a:t>
+            </a:r>
+          </a:p>
+          <a:p>
+            <a:r>
+              <a:t>The original coverage chart compares 40, 25 and 13 test months; the 13-month change interval crosses zero. Coverage filtering changes training and test month composition. The additional longer-lag experiment uses a separate common sample of 30 test months. Same-event examples are descriptive headline comparisons, not causal identification.</a:t>
             </a:r>
           </a:p>
         </p:txBody>
@@ -6890,6 +6966,7 @@
           </a:lstStyle>
           <a:p>
             <a:pPr>
+              <a:buNone/>
               <a:defRPr sz="2175" b="1">
                 <a:solidFill>
                   <a:srgbClr val="252B29"/>
@@ -6908,7 +6985,7 @@
                 <a:ea typeface="Arial"/>
                 <a:cs typeface="Arial"/>
               </a:rPr>
-              <a:t>Prices and benchmark choice change the interpretation</a:t>
+              <a:t>Implications for financial forecasting and risk monitoring</a:t>
             </a:r>
           </a:p>
         </p:txBody>
@@ -7352,6 +7429,7 @@
           </a:lstStyle>
           <a:p>
             <a:pPr>
+              <a:buNone/>
               <a:defRPr sz="2550" b="1">
                 <a:solidFill>
                   <a:srgbClr val="252B29"/>
@@ -7370,7 +7448,7 @@
                 <a:ea typeface="Arial"/>
                 <a:cs typeface="Arial"/>
               </a:rPr>
-              <a:t>Media forecasting gains depend on controls and coverage</a:t>
+              <a:t>Media gains remain uncertain after additional checks</a:t>
             </a:r>
           </a:p>
         </p:txBody>
@@ -7418,6 +7496,7 @@
           </a:lstStyle>
           <a:p>
             <a:pPr>
+              <a:buNone/>
               <a:defRPr sz="1350" b="0">
                 <a:solidFill>
                   <a:srgbClr val="68766E"/>
@@ -7436,7 +7515,31 @@
                 <a:ea typeface="Arial"/>
                 <a:cs typeface="Arial"/>
               </a:rPr>
-              <a:t>Forecasting implication: purchasing power and recent sentiment deserve priority before adding more text features.</a:t>
+              <a:t>Check the benchmark before interpreting a sentiment gap as risk information.</a:t>
+            </a:r>
+          </a:p>
+          <a:p>
+            <a:pPr>
+              <a:buNone/>
+              <a:defRPr sz="1350" b="0">
+                <a:solidFill>
+                  <a:srgbClr val="68766E"/>
+                </a:solidFill>
+                <a:latin typeface="Arial"/>
+                <a:ea typeface="Arial"/>
+                <a:cs typeface="Arial"/>
+              </a:defRPr>
+            </a:pPr>
+            <a:r>
+              <a:rPr sz="1350" b="0">
+                <a:solidFill>
+                  <a:srgbClr val="68766E"/>
+                </a:solidFill>
+                <a:latin typeface="Arial"/>
+                <a:ea typeface="Arial"/>
+                <a:cs typeface="Arial"/>
+              </a:rPr>
+              <a:t>August gap: −14.4 versus economy-only; −3.5 versus prior sentiment.</a:t>
             </a:r>
           </a:p>
         </p:txBody>
@@ -8486,6 +8589,7 @@
           </a:lstStyle>
           <a:p>
             <a:pPr>
+              <a:buNone/>
               <a:defRPr sz="1350" b="0">
                 <a:solidFill>
                   <a:srgbClr val="68766E"/>
@@ -8504,7 +8608,31 @@
                 <a:ea typeface="Arial"/>
                 <a:cs typeface="Arial"/>
               </a:rPr>
-              <a:t>230 eligible headlines + 829 X posts from 1,473 coded texts. October 2019–July 2026. Selected sample.</a:t>
+              <a:t>Corpus: 230 headlines + 829 X posts, October 2019–July 2026.</a:t>
+            </a:r>
+          </a:p>
+          <a:p>
+            <a:pPr>
+              <a:buNone/>
+              <a:defRPr sz="1350" b="0">
+                <a:solidFill>
+                  <a:srgbClr val="68766E"/>
+                </a:solidFill>
+                <a:latin typeface="Arial"/>
+                <a:ea typeface="Arial"/>
+                <a:cs typeface="Arial"/>
+              </a:defRPr>
+            </a:pPr>
+            <a:r>
+              <a:rPr sz="1350" b="0">
+                <a:solidFill>
+                  <a:srgbClr val="68766E"/>
+                </a:solidFill>
+                <a:latin typeface="Arial"/>
+                <a:ea typeface="Arial"/>
+                <a:cs typeface="Arial"/>
+              </a:rPr>
+              <a:t>One human reference. Held-out tone macro-F1: 0.602 (196 valid pairs).</a:t>
             </a:r>
           </a:p>
         </p:txBody>
@@ -10769,6 +10897,7 @@
           </a:lstStyle>
           <a:p>
             <a:pPr>
+              <a:buNone/>
               <a:defRPr sz="2175" b="1">
                 <a:solidFill>
                   <a:srgbClr val="252B29"/>
@@ -10787,7 +10916,7 @@
                 <a:ea typeface="Arial"/>
                 <a:cs typeface="Arial"/>
               </a:rPr>
-              <a:t>Media helps in one controlled specification, with limited stability</a:t>
+              <a:t>Media gains remain uncertain after robustness checks</a:t>
             </a:r>
           </a:p>
         </p:txBody>
@@ -10989,6 +11118,7 @@
           </a:lstStyle>
           <a:p>
             <a:pPr>
+              <a:buNone/>
               <a:defRPr sz="1350" b="0">
                 <a:solidFill>
                   <a:srgbClr val="68766E"/>
@@ -11007,7 +11137,31 @@
                 <a:ea typeface="Arial"/>
                 <a:cs typeface="Arial"/>
               </a:rPr>
-              <a:t>Same 40 test months, January 2023–August 2026. Expanding ridge regression. Method control: 2024 web transition.</a:t>
+              <a:t>Same 40 test months, January 2023–August 2026.</a:t>
+            </a:r>
+          </a:p>
+          <a:p>
+            <a:pPr>
+              <a:buNone/>
+              <a:defRPr sz="1350" b="0">
+                <a:solidFill>
+                  <a:srgbClr val="68766E"/>
+                </a:solidFill>
+                <a:latin typeface="Arial"/>
+                <a:ea typeface="Arial"/>
+                <a:cs typeface="Arial"/>
+              </a:defRPr>
+            </a:pPr>
+            <a:r>
+              <a:rPr sz="1350" b="0">
+                <a:solidFill>
+                  <a:srgbClr val="68766E"/>
+                </a:solidFill>
+                <a:latin typeface="Arial"/>
+                <a:ea typeface="Arial"/>
+                <a:cs typeface="Arial"/>
+              </a:rPr>
+              <a:t>Holm-adjusted p = 0.147 across 14 original comparisons.</a:t>
             </a:r>
           </a:p>
         </p:txBody>
@@ -11380,8 +11534,8 @@
         </p:nvSpPr>
         <p:spPr>
           <a:xfrm>
-            <a:off x="571500" y="6238875"/>
-            <a:ext cx="10429875" cy="285750"/>
+            <a:off x="571500" y="6172200"/>
+            <a:ext cx="10429875" cy="476250"/>
           </a:xfrm>
           <a:prstGeom prst="rect">
             <a:avLst/>
@@ -11426,7 +11580,31 @@
                 <a:ea typeface="Arial"/>
                 <a:cs typeface="Arial"/>
               </a:rPr>
-              <a:t>Minimum items per month. Seasonality/survey-mode controls. Filters change training and test months.</a:t>
+              <a:t>Coverage filters change training and test months. Seasonality/survey-mode controls.</a:t>
+            </a:r>
+          </a:p>
+          <a:p>
+            <a:pPr>
+              <a:buNone/>
+              <a:defRPr sz="1275" b="0">
+                <a:solidFill>
+                  <a:srgbClr val="68766E"/>
+                </a:solidFill>
+                <a:latin typeface="Arial"/>
+                <a:ea typeface="Arial"/>
+                <a:cs typeface="Arial"/>
+              </a:defRPr>
+            </a:pPr>
+            <a:r>
+              <a:rPr sz="1275" b="0">
+                <a:solidFill>
+                  <a:srgbClr val="68766E"/>
+                </a:solidFill>
+                <a:latin typeface="Arial"/>
+                <a:ea typeface="Arial"/>
+                <a:cs typeface="Arial"/>
+              </a:rPr>
+              <a:t>Longer-lag checks use a separate 30-month sample.</a:t>
             </a:r>
           </a:p>
         </p:txBody>

</xml_diff>